<commit_message>
Add live demo and GitHub links to PPT deck and README
</commit_message>
<xml_diff>
--- a/SBI_Dost_Idea_Deck.pptx
+++ b/SBI_Dost_Idea_Deck.pptx
@@ -3379,7 +3379,7 @@
         </p:nvSpPr>
         <p:spPr>
           <a:xfrm>
-            <a:off x="914400" y="5577840"/>
+            <a:off x="914400" y="5303520"/>
             <a:ext cx="5486400" cy="365760"/>
           </a:xfrm>
           <a:prstGeom prst="rect">
@@ -3409,7 +3409,43 @@
       </p:sp>
       <p:sp>
         <p:nvSpPr>
-          <p:cNvPr id="10" name="Rounded Rectangle 9"/>
+          <p:cNvPr id="10" name="TextBox 9"/>
+          <p:cNvSpPr txBox="1"/>
+          <p:nvPr/>
+        </p:nvSpPr>
+        <p:spPr>
+          <a:xfrm>
+            <a:off x="914400" y="5760720"/>
+            <a:ext cx="9144000" cy="365760"/>
+          </a:xfrm>
+          <a:prstGeom prst="rect">
+            <a:avLst/>
+          </a:prstGeom>
+          <a:noFill/>
+        </p:spPr>
+        <p:txBody>
+          <a:bodyPr wrap="square">
+            <a:spAutoFit/>
+          </a:bodyPr>
+          <a:lstStyle/>
+          <a:p>
+            <a:pPr algn="l">
+              <a:defRPr sz="1100" b="0">
+                <a:solidFill>
+                  <a:srgbClr val="38BDF8"/>
+                </a:solidFill>
+                <a:latin typeface="Calibri"/>
+              </a:defRPr>
+            </a:pPr>
+            <a:r>
+              <a:t>Live Demo: sbi-agentic-banking-hackathon.vercel.app   |   GitHub: github.com/JatinGargz/sbi-dost</a:t>
+            </a:r>
+          </a:p>
+        </p:txBody>
+      </p:sp>
+      <p:sp>
+        <p:nvSpPr>
+          <p:cNvPr id="11" name="Rounded Rectangle 10"/>
           <p:cNvSpPr/>
           <p:nvPr/>
         </p:nvSpPr>
@@ -3452,7 +3488,7 @@
       </p:sp>
       <p:sp>
         <p:nvSpPr>
-          <p:cNvPr id="11" name="TextBox 10"/>
+          <p:cNvPr id="12" name="TextBox 11"/>
           <p:cNvSpPr txBox="1"/>
           <p:nvPr/>
         </p:nvSpPr>
@@ -3488,7 +3524,7 @@
       </p:sp>
       <p:sp>
         <p:nvSpPr>
-          <p:cNvPr id="12" name="TextBox 11"/>
+          <p:cNvPr id="13" name="TextBox 12"/>
           <p:cNvSpPr txBox="1"/>
           <p:nvPr/>
         </p:nvSpPr>
@@ -3714,8 +3750,44 @@
         </p:nvSpPr>
         <p:spPr>
           <a:xfrm>
-            <a:off x="2743200" y="3840480"/>
+            <a:off x="2743200" y="3657600"/>
             <a:ext cx="7315200" cy="457200"/>
+          </a:xfrm>
+          <a:prstGeom prst="rect">
+            <a:avLst/>
+          </a:prstGeom>
+          <a:noFill/>
+        </p:spPr>
+        <p:txBody>
+          <a:bodyPr wrap="square">
+            <a:spAutoFit/>
+          </a:bodyPr>
+          <a:lstStyle/>
+          <a:p>
+            <a:pPr algn="ctr">
+              <a:defRPr sz="1600" b="1">
+                <a:solidFill>
+                  <a:srgbClr val="38BDF8"/>
+                </a:solidFill>
+                <a:latin typeface="Calibri"/>
+              </a:defRPr>
+            </a:pPr>
+            <a:r>
+              <a:t>Live Demo: sbi-agentic-banking-hackathon.vercel.app</a:t>
+            </a:r>
+          </a:p>
+        </p:txBody>
+      </p:sp>
+      <p:sp>
+        <p:nvSpPr>
+          <p:cNvPr id="7" name="TextBox 6"/>
+          <p:cNvSpPr txBox="1"/>
+          <p:nvPr/>
+        </p:nvSpPr>
+        <p:spPr>
+          <a:xfrm>
+            <a:off x="2743200" y="4114800"/>
+            <a:ext cx="7315200" cy="365760"/>
           </a:xfrm>
           <a:prstGeom prst="rect">
             <a:avLst/>
@@ -3737,20 +3809,20 @@
               </a:defRPr>
             </a:pPr>
             <a:r>
-              <a:t>Prototype Live  •  GitHub Repository Ready  •  3-Minute Demo Available</a:t>
-            </a:r>
-          </a:p>
-        </p:txBody>
-      </p:sp>
-      <p:sp>
-        <p:nvSpPr>
-          <p:cNvPr id="7" name="TextBox 6"/>
-          <p:cNvSpPr txBox="1"/>
-          <p:nvPr/>
-        </p:nvSpPr>
-        <p:spPr>
-          <a:xfrm>
-            <a:off x="2743200" y="4754880"/>
+              <a:t>GitHub: github.com/JatinGargz/sbi-dost</a:t>
+            </a:r>
+          </a:p>
+        </p:txBody>
+      </p:sp>
+      <p:sp>
+        <p:nvSpPr>
+          <p:cNvPr id="8" name="TextBox 7"/>
+          <p:cNvSpPr txBox="1"/>
+          <p:nvPr/>
+        </p:nvSpPr>
+        <p:spPr>
+          <a:xfrm>
+            <a:off x="2743200" y="4846320"/>
             <a:ext cx="7315200" cy="365760"/>
           </a:xfrm>
           <a:prstGeom prst="rect">
@@ -3780,13 +3852,13 @@
       </p:sp>
       <p:sp>
         <p:nvSpPr>
-          <p:cNvPr id="8" name="TextBox 7"/>
-          <p:cNvSpPr txBox="1"/>
-          <p:nvPr/>
-        </p:nvSpPr>
-        <p:spPr>
-          <a:xfrm>
-            <a:off x="2743200" y="5212080"/>
+          <p:cNvPr id="9" name="TextBox 8"/>
+          <p:cNvSpPr txBox="1"/>
+          <p:nvPr/>
+        </p:nvSpPr>
+        <p:spPr>
+          <a:xfrm>
+            <a:off x="2743200" y="5303520"/>
             <a:ext cx="7315200" cy="365760"/>
           </a:xfrm>
           <a:prstGeom prst="rect">
@@ -3816,7 +3888,7 @@
       </p:sp>
       <p:sp>
         <p:nvSpPr>
-          <p:cNvPr id="9" name="Rounded Rectangle 8"/>
+          <p:cNvPr id="10" name="Rounded Rectangle 9"/>
           <p:cNvSpPr/>
           <p:nvPr/>
         </p:nvSpPr>
@@ -3859,7 +3931,7 @@
       </p:sp>
       <p:sp>
         <p:nvSpPr>
-          <p:cNvPr id="10" name="TextBox 9"/>
+          <p:cNvPr id="11" name="TextBox 10"/>
           <p:cNvSpPr txBox="1"/>
           <p:nvPr/>
         </p:nvSpPr>
@@ -3895,7 +3967,7 @@
       </p:sp>
       <p:sp>
         <p:nvSpPr>
-          <p:cNvPr id="11" name="TextBox 10"/>
+          <p:cNvPr id="12" name="TextBox 11"/>
           <p:cNvSpPr txBox="1"/>
           <p:nvPr/>
         </p:nvSpPr>

</xml_diff>

<commit_message>
Add Supademo interactive walkthrough link to proposal and slides
</commit_message>
<xml_diff>
--- a/SBI_Dost_Idea_Deck.pptx
+++ b/SBI_Dost_Idea_Deck.pptx
@@ -3416,7 +3416,7 @@
         <p:spPr>
           <a:xfrm>
             <a:off x="914400" y="5760720"/>
-            <a:ext cx="9144000" cy="365760"/>
+            <a:ext cx="10515600" cy="365760"/>
           </a:xfrm>
           <a:prstGeom prst="rect">
             <a:avLst/>
@@ -3430,7 +3430,7 @@
           <a:lstStyle/>
           <a:p>
             <a:pPr algn="l">
-              <a:defRPr sz="1100" b="0">
+              <a:defRPr sz="1000" b="0">
                 <a:solidFill>
                   <a:srgbClr val="38BDF8"/>
                 </a:solidFill>
@@ -3438,7 +3438,7 @@
               </a:defRPr>
             </a:pPr>
             <a:r>
-              <a:t>Live Demo: sbi-agentic-banking-hackathon.vercel.app   |   GitHub: github.com/JatinGargz/sbi-dost</a:t>
+              <a:t>Live Demo: sbi-agentic-banking-hackathon.vercel.app   |   Interactive Tour: supademo.com/demo/cmr3tms0u0emvqmkqw1v0gnte</a:t>
             </a:r>
           </a:p>
         </p:txBody>
@@ -3801,7 +3801,43 @@
           <a:lstStyle/>
           <a:p>
             <a:pPr algn="ctr">
-              <a:defRPr sz="1400" b="0">
+              <a:defRPr sz="1400" b="1">
+                <a:solidFill>
+                  <a:srgbClr val="FFFFFF"/>
+                </a:solidFill>
+                <a:latin typeface="Calibri"/>
+              </a:defRPr>
+            </a:pPr>
+            <a:r>
+              <a:t>Interactive Tour: supademo.com/demo/cmr3tms0u0emvqmkqw1v0gnte</a:t>
+            </a:r>
+          </a:p>
+        </p:txBody>
+      </p:sp>
+      <p:sp>
+        <p:nvSpPr>
+          <p:cNvPr id="8" name="TextBox 7"/>
+          <p:cNvSpPr txBox="1"/>
+          <p:nvPr/>
+        </p:nvSpPr>
+        <p:spPr>
+          <a:xfrm>
+            <a:off x="2743200" y="4572000"/>
+            <a:ext cx="7315200" cy="365760"/>
+          </a:xfrm>
+          <a:prstGeom prst="rect">
+            <a:avLst/>
+          </a:prstGeom>
+          <a:noFill/>
+        </p:spPr>
+        <p:txBody>
+          <a:bodyPr wrap="square">
+            <a:spAutoFit/>
+          </a:bodyPr>
+          <a:lstStyle/>
+          <a:p>
+            <a:pPr algn="ctr">
+              <a:defRPr sz="1200" b="0">
                 <a:solidFill>
                   <a:srgbClr val="94A3B8"/>
                 </a:solidFill>
@@ -3816,13 +3852,13 @@
       </p:sp>
       <p:sp>
         <p:nvSpPr>
-          <p:cNvPr id="8" name="TextBox 7"/>
-          <p:cNvSpPr txBox="1"/>
-          <p:nvPr/>
-        </p:nvSpPr>
-        <p:spPr>
-          <a:xfrm>
-            <a:off x="2743200" y="4846320"/>
+          <p:cNvPr id="9" name="TextBox 8"/>
+          <p:cNvSpPr txBox="1"/>
+          <p:nvPr/>
+        </p:nvSpPr>
+        <p:spPr>
+          <a:xfrm>
+            <a:off x="2743200" y="5120640"/>
             <a:ext cx="7315200" cy="365760"/>
           </a:xfrm>
           <a:prstGeom prst="rect">
@@ -3852,13 +3888,13 @@
       </p:sp>
       <p:sp>
         <p:nvSpPr>
-          <p:cNvPr id="9" name="TextBox 8"/>
-          <p:cNvSpPr txBox="1"/>
-          <p:nvPr/>
-        </p:nvSpPr>
-        <p:spPr>
-          <a:xfrm>
-            <a:off x="2743200" y="5303520"/>
+          <p:cNvPr id="10" name="TextBox 9"/>
+          <p:cNvSpPr txBox="1"/>
+          <p:nvPr/>
+        </p:nvSpPr>
+        <p:spPr>
+          <a:xfrm>
+            <a:off x="2743200" y="5577840"/>
             <a:ext cx="7315200" cy="365760"/>
           </a:xfrm>
           <a:prstGeom prst="rect">
@@ -3888,7 +3924,7 @@
       </p:sp>
       <p:sp>
         <p:nvSpPr>
-          <p:cNvPr id="10" name="Rounded Rectangle 9"/>
+          <p:cNvPr id="11" name="Rounded Rectangle 10"/>
           <p:cNvSpPr/>
           <p:nvPr/>
         </p:nvSpPr>
@@ -3931,7 +3967,7 @@
       </p:sp>
       <p:sp>
         <p:nvSpPr>
-          <p:cNvPr id="11" name="TextBox 10"/>
+          <p:cNvPr id="12" name="TextBox 11"/>
           <p:cNvSpPr txBox="1"/>
           <p:nvPr/>
         </p:nvSpPr>
@@ -3967,7 +4003,7 @@
       </p:sp>
       <p:sp>
         <p:nvSpPr>
-          <p:cNvPr id="12" name="TextBox 11"/>
+          <p:cNvPr id="13" name="TextBox 12"/>
           <p:cNvSpPr txBox="1"/>
           <p:nvPr/>
         </p:nvSpPr>
@@ -12722,7 +12758,43 @@
       </p:sp>
       <p:sp>
         <p:nvSpPr>
-          <p:cNvPr id="4" name="Rounded Rectangle 3"/>
+          <p:cNvPr id="4" name="TextBox 3"/>
+          <p:cNvSpPr txBox="1"/>
+          <p:nvPr/>
+        </p:nvSpPr>
+        <p:spPr>
+          <a:xfrm>
+            <a:off x="731520" y="1371600"/>
+            <a:ext cx="10058400" cy="365760"/>
+          </a:xfrm>
+          <a:prstGeom prst="rect">
+            <a:avLst/>
+          </a:prstGeom>
+          <a:noFill/>
+        </p:spPr>
+        <p:txBody>
+          <a:bodyPr wrap="square">
+            <a:spAutoFit/>
+          </a:bodyPr>
+          <a:lstStyle/>
+          <a:p>
+            <a:pPr algn="l">
+              <a:defRPr sz="1100" b="1">
+                <a:solidFill>
+                  <a:srgbClr val="0066CC"/>
+                </a:solidFill>
+                <a:latin typeface="Calibri"/>
+              </a:defRPr>
+            </a:pPr>
+            <a:r>
+              <a:t>👉 Interactive Guided Walkthrough: https://app.supademo.com/demo/cmr3tms0u0emvqmkqw1v0gnte</a:t>
+            </a:r>
+          </a:p>
+        </p:txBody>
+      </p:sp>
+      <p:sp>
+        <p:nvSpPr>
+          <p:cNvPr id="5" name="Rounded Rectangle 4"/>
           <p:cNvSpPr/>
           <p:nvPr/>
         </p:nvSpPr>
@@ -12767,7 +12839,7 @@
       </p:sp>
       <p:sp>
         <p:nvSpPr>
-          <p:cNvPr id="5" name="TextBox 4"/>
+          <p:cNvPr id="6" name="TextBox 5"/>
           <p:cNvSpPr txBox="1"/>
           <p:nvPr/>
         </p:nvSpPr>
@@ -12803,7 +12875,7 @@
       </p:sp>
       <p:sp>
         <p:nvSpPr>
-          <p:cNvPr id="6" name="TextBox 5"/>
+          <p:cNvPr id="7" name="TextBox 6"/>
           <p:cNvSpPr txBox="1"/>
           <p:nvPr/>
         </p:nvSpPr>
@@ -12839,7 +12911,7 @@
       </p:sp>
       <p:sp>
         <p:nvSpPr>
-          <p:cNvPr id="7" name="Rounded Rectangle 6"/>
+          <p:cNvPr id="8" name="Rounded Rectangle 7"/>
           <p:cNvSpPr/>
           <p:nvPr/>
         </p:nvSpPr>
@@ -12884,7 +12956,7 @@
       </p:sp>
       <p:sp>
         <p:nvSpPr>
-          <p:cNvPr id="8" name="TextBox 7"/>
+          <p:cNvPr id="9" name="TextBox 8"/>
           <p:cNvSpPr txBox="1"/>
           <p:nvPr/>
         </p:nvSpPr>
@@ -12920,7 +12992,7 @@
       </p:sp>
       <p:sp>
         <p:nvSpPr>
-          <p:cNvPr id="9" name="TextBox 8"/>
+          <p:cNvPr id="10" name="TextBox 9"/>
           <p:cNvSpPr txBox="1"/>
           <p:nvPr/>
         </p:nvSpPr>
@@ -12956,7 +13028,7 @@
       </p:sp>
       <p:sp>
         <p:nvSpPr>
-          <p:cNvPr id="10" name="Rounded Rectangle 9"/>
+          <p:cNvPr id="11" name="Rounded Rectangle 10"/>
           <p:cNvSpPr/>
           <p:nvPr/>
         </p:nvSpPr>
@@ -13001,7 +13073,7 @@
       </p:sp>
       <p:sp>
         <p:nvSpPr>
-          <p:cNvPr id="11" name="TextBox 10"/>
+          <p:cNvPr id="12" name="TextBox 11"/>
           <p:cNvSpPr txBox="1"/>
           <p:nvPr/>
         </p:nvSpPr>
@@ -13037,7 +13109,7 @@
       </p:sp>
       <p:sp>
         <p:nvSpPr>
-          <p:cNvPr id="12" name="TextBox 11"/>
+          <p:cNvPr id="13" name="TextBox 12"/>
           <p:cNvSpPr txBox="1"/>
           <p:nvPr/>
         </p:nvSpPr>
@@ -13073,7 +13145,7 @@
       </p:sp>
       <p:sp>
         <p:nvSpPr>
-          <p:cNvPr id="13" name="Rounded Rectangle 12"/>
+          <p:cNvPr id="14" name="Rounded Rectangle 13"/>
           <p:cNvSpPr/>
           <p:nvPr/>
         </p:nvSpPr>
@@ -13118,7 +13190,7 @@
       </p:sp>
       <p:sp>
         <p:nvSpPr>
-          <p:cNvPr id="14" name="TextBox 13"/>
+          <p:cNvPr id="15" name="TextBox 14"/>
           <p:cNvSpPr txBox="1"/>
           <p:nvPr/>
         </p:nvSpPr>
@@ -13154,7 +13226,7 @@
       </p:sp>
       <p:sp>
         <p:nvSpPr>
-          <p:cNvPr id="15" name="TextBox 14"/>
+          <p:cNvPr id="16" name="TextBox 15"/>
           <p:cNvSpPr txBox="1"/>
           <p:nvPr/>
         </p:nvSpPr>
@@ -13190,7 +13262,7 @@
       </p:sp>
       <p:sp>
         <p:nvSpPr>
-          <p:cNvPr id="16" name="Rounded Rectangle 15"/>
+          <p:cNvPr id="17" name="Rounded Rectangle 16"/>
           <p:cNvSpPr/>
           <p:nvPr/>
         </p:nvSpPr>
@@ -13233,7 +13305,7 @@
       </p:sp>
       <p:sp>
         <p:nvSpPr>
-          <p:cNvPr id="17" name="TextBox 16"/>
+          <p:cNvPr id="18" name="TextBox 17"/>
           <p:cNvSpPr txBox="1"/>
           <p:nvPr/>
         </p:nvSpPr>
@@ -13269,7 +13341,7 @@
       </p:sp>
       <p:sp>
         <p:nvSpPr>
-          <p:cNvPr id="18" name="TextBox 17"/>
+          <p:cNvPr id="19" name="TextBox 18"/>
           <p:cNvSpPr txBox="1"/>
           <p:nvPr/>
         </p:nvSpPr>

</xml_diff>

<commit_message>
Add demo video Google Drive link to proposal, PPT slides 1/9/10, and README
</commit_message>
<xml_diff>
--- a/SBI_Dost_Idea_Deck.pptx
+++ b/SBI_Dost_Idea_Deck.pptx
@@ -3438,7 +3438,7 @@
               </a:defRPr>
             </a:pPr>
             <a:r>
-              <a:t>Live Demo: sbi-agentic-banking-hackathon.vercel.app   |   Interactive Tour: supademo.com/demo/cmr3tms0u0emvqmkqw1v0gnte</a:t>
+              <a:t>Demo Video: drive.google.com/file/d/1ap6l   |   Live Site: sbi-agentic-banking-hackathon.vercel.app   |   GitHub: github.com/JatinGargz/sbi-dost</a:t>
             </a:r>
           </a:p>
         </p:txBody>
@@ -3773,7 +3773,7 @@
               </a:defRPr>
             </a:pPr>
             <a:r>
-              <a:t>Live Demo: sbi-agentic-banking-hackathon.vercel.app</a:t>
+              <a:t>Demo Video: drive.google.com/file/d/1ap6l</a:t>
             </a:r>
           </a:p>
         </p:txBody>
@@ -3809,7 +3809,7 @@
               </a:defRPr>
             </a:pPr>
             <a:r>
-              <a:t>Interactive Tour: supademo.com/demo/cmr3tms0u0emvqmkqw1v0gnte</a:t>
+              <a:t>Live Site: sbi-agentic-banking-hackathon.vercel.app</a:t>
             </a:r>
           </a:p>
         </p:txBody>
@@ -12787,7 +12787,7 @@
               </a:defRPr>
             </a:pPr>
             <a:r>
-              <a:t>👉 Interactive Guided Walkthrough: https://app.supademo.com/demo/cmr3tms0u0emvqmkqw1v0gnte</a:t>
+              <a:t>Demo Video: drive.google.com/file/d/1ap6l   |   Interactive Tour: supademo.com/demo/cmr3tms0u0emvqmkqw1v0gnte</a:t>
             </a:r>
           </a:p>
         </p:txBody>

</xml_diff>